<commit_message>
site: deck says nine shipped shapes, which is the count
Co-Authored-By: Claude Fable 5.1 <noreply@anthropic.com>
</commit_message>
<xml_diff>
--- a/fluidfix-deck.pptx
+++ b/fluidfix-deck.pptx
@@ -1039,7 +1039,7 @@
           <a:p>
             <a:r>
               <a:rPr lang="en-US" dirty="0"/>
-              <a:t>Out of the box it repairs thirteen shapes of mechanical bug. The part that compounds: every incident you have had becomes a class it repairs from then on, from one example. Real history: one example from a 2016 cglm commit produced the correct repair for four fixes spanning 2016 to 2023 across four files. Your incident log is the asset.</a:t>
+              <a:t>Out of the box it repairs nine shapes of mechanical bug. The part that compounds: every incident you have had becomes a class it repairs from then on, from one example. Real history: one example from a 2016 cglm commit produced the correct repair for four fixes spanning 2016 to 2023 across four files. Your incident log is the asset.</a:t>
             </a:r>
             <a:endParaRPr lang="en-US" dirty="0"/>
           </a:p>
@@ -6427,7 +6427,7 @@
                 <a:ea typeface="Calibri" pitchFamily="34" charset="-122"/>
                 <a:cs typeface="Calibri" pitchFamily="34" charset="-120"/>
               </a:rPr>
-              <a:t>Thirteen shapes of mechanical bug are repaired out of the box: flipped operators, off-by-one, swapped operands, min/max, booleans, comparisons.</a:t>
+              <a:t>Nine shapes of mechanical bug are repaired out of the box: flipped operators, off-by-one, swapped operands, min/max, booleans, comparisons.</a:t>
             </a:r>
             <a:endParaRPr lang="en-US" sz="1500" dirty="0"/>
           </a:p>
@@ -6700,7 +6700,7 @@
                 <a:ea typeface="Courier New" pitchFamily="34" charset="-122"/>
                 <a:cs typeface="Courier New" pitchFamily="34" charset="-120"/>
               </a:rPr>
-              <a:t>13</a:t>
+              <a:t>9</a:t>
             </a:r>
             <a:endParaRPr lang="en-US" sz="3000" dirty="0"/>
           </a:p>

</xml_diff>